<commit_message>
Updated the PDF Viewer sample
</commit_message>
<xml_diff>
--- a/syncfusion-viewer/public/MarketOpportunity.pptx
+++ b/syncfusion-viewer/public/MarketOpportunity.pptx
@@ -772,7 +772,7 @@
             <a:pPr algn="r"/>
             <a:fld id="{5ABAEF09-C7AA-4246-A651-C392B302FD5F}" type="datetimeFigureOut">
               <a:rPr lang="en-US"/>
-              <a:t>8/7/2026</a:t>
+              <a:t>8/12/2026</a:t>
             </a:fld>
             <a:endParaRPr/>
           </a:p>
@@ -1218,12 +1218,35 @@
           <a:bodyPr wrap="square"/>
           <a:lstStyle/>
           <a:p>
-            <a:endParaRPr/>
-          </a:p>
-          <a:p>
-            <a:r>
-              <a:t>This 2x2 positions us in the high-capability, competitive-price quadrant — the ideal growth zone. Legacy Vendor A has capability but is expensive and slow to innovate (they lose deals on agility). Competitor B is price-competitive but low-capability — customers outgrow them. Niche Player C and Competitor D occupy defensible niches but lack breadth. We win on the combination of AI-native architecture, open APIs, and superior support SLAs. Key objection to prepare for: 'Why not just use Competitor D?' — answer is our API-first model and lack of vendor lock-in.</a:t>
-            </a:r>
+            <a:pPr fontAlgn="t"/>
+            <a:r>
+              <a:rPr lang="en-US" sz="1200" b="0" i="0" dirty="0">
+                <a:effectLst/>
+                <a:latin typeface="Calibri"/>
+                <a:ea typeface="Calibri"/>
+                <a:cs typeface="Calibri"/>
+              </a:rPr>
+              <a:t>This 2x2 positions us in the high-capability, competitive-price quadrant, the ideal growth zone. Legacy Vendor A offers strong capabilities but is expensive and slower to innovate, often losing opportunities due to limited agility. Competitor B is competitively priced but lacks the capabilities required by growing customers. Niche Player C and Competitor D serve specific market segments well but lack broader platform capabilities. We differentiate ourselves through our AI-native architecture, open APIs, and superior support SLAs. When asked, "Why not just use Competitor </a:t>
+            </a:r>
+            <a:r>
+              <a:rPr lang="en-US" sz="1200" b="0" i="0">
+                <a:effectLst/>
+                <a:latin typeface="Calibri"/>
+                <a:ea typeface="Calibri"/>
+                <a:cs typeface="Calibri"/>
+              </a:rPr>
+              <a:t>D?" answer </a:t>
+            </a:r>
+            <a:r>
+              <a:rPr lang="en-US" sz="1200" b="0" i="0" dirty="0">
+                <a:effectLst/>
+                <a:latin typeface="Calibri"/>
+                <a:ea typeface="Calibri"/>
+                <a:cs typeface="Calibri"/>
+              </a:rPr>
+              <a:t>is our API-first model and lack of vendor lock-in.</a:t>
+            </a:r>
+            <a:endParaRPr lang="en-US" dirty="0"/>
           </a:p>
         </p:txBody>
       </p:sp>
@@ -1325,11 +1348,12 @@
           <a:bodyPr wrap="square"/>
           <a:lstStyle/>
           <a:p>
-            <a:endParaRPr/>
-          </a:p>
-          <a:p>
-            <a:r>
-              <a:t>Present all three scenarios — investors appreciate seeing conservative, base, and aggressive cases. Base case ($400M ARR by 2029) is our internal operating plan; requires $35M ARR in 2026 as the on-ramp. 75% gross margin is achievable given our SaaS-first architecture with minimal COGS. Net Revenue Retention &gt;120% is our North Star metric — it means existing customers expand faster than any churn. This is the key indicator VCs will focus on. Be ready to walk through the unit economics: CAC payback period of 18 months, LTV:CAC of 5:1.</a:t>
+            <a:endParaRPr lang="en-US" dirty="0"/>
+          </a:p>
+          <a:p>
+            <a:r>
+              <a:rPr lang="en-US" dirty="0"/>
+              <a:t>Present all three scenarios investors appreciate seeing conservative, base, and aggressive cases. Base case ($400M ARR by 2029) is our internal operating plan; requires $35M ARR in 2026 as the on-ramp. 75% gross margin is achievable given our SaaS-first architecture with minimal COGS. Net Revenue Retention &gt;120% is our North Star metric. It means existing customers expand faster than any churn. This is the key indicator VCs will focus on. Be ready to walk through the unit economics: CAC payback period of 18 months, LTV:CAC of 5:1.</a:t>
             </a:r>
           </a:p>
         </p:txBody>
@@ -1534,11 +1558,12 @@
           <a:bodyPr wrap="square"/>
           <a:lstStyle/>
           <a:p>
-            <a:endParaRPr/>
-          </a:p>
-          <a:p>
-            <a:r>
-              <a:t>Close strongly with a clear and specific call to action. Step 01 (Demo): Have a calendar link ready — suggest booking before they leave the room. Step 02 (Research report): The full 40-page report is available on our website; send the link in follow-up email. Step 03 (ROI analysis): This is the highest-intent action — have your enterprise AE follow up within 24 hours. Step 04 (Pilot program): 90-day pilot with guaranteed POV outcome is our strongest deal-closer — zero-risk entry for prospects. Thank the audience, invite Q&amp;A, and remind them of the follow-up materials you will send.</a:t>
+            <a:endParaRPr dirty="0"/>
+          </a:p>
+          <a:p>
+            <a:r>
+              <a:rPr dirty="0"/>
+              <a:t>Close strongly with a clear and specific call to action. Step 01 (Demo): Have a calendar link ready suggest booking before they leave the room. Step 02 (Research report): The full 40-page report is available on our website; send the link in follow-up email. Step 03 (ROI analysis): This is the highest-intent action have your enterprise AE follow up within 24 hours. Step 04 (Pilot program): 90-day pilot with guaranteed POV outcome is our strongest deal-closer zero-risk entry for prospects. Thank the audience, invite Q&amp;A, and remind them of the follow-up materials you will send.</a:t>
             </a:r>
           </a:p>
         </p:txBody>
@@ -1722,7 +1747,7 @@
           <a:p>
             <a:fld id="{D4630D1D-EC81-4D12-BBAE-7AD5C46FE905}" type="datetimeFigureOut">
               <a:rPr lang="en-US" dirty="0"/>
-              <a:t>8/7/2026</a:t>
+              <a:t>8/12/2026</a:t>
             </a:fld>
             <a:endParaRPr lang="en-US" dirty="0"/>
           </a:p>
@@ -1909,7 +1934,7 @@
           <a:p>
             <a:fld id="{D4630D1D-EC81-4D12-BBAE-7AD5C46FE905}" type="datetimeFigureOut">
               <a:rPr lang="en-US" dirty="0"/>
-              <a:t>8/7/2026</a:t>
+              <a:t>8/12/2026</a:t>
             </a:fld>
             <a:endParaRPr lang="en-US" dirty="0"/>
           </a:p>
@@ -2104,7 +2129,7 @@
           <a:p>
             <a:fld id="{D4630D1D-EC81-4D12-BBAE-7AD5C46FE905}" type="datetimeFigureOut">
               <a:rPr lang="en-US" dirty="0"/>
-              <a:t>8/7/2026</a:t>
+              <a:t>8/12/2026</a:t>
             </a:fld>
             <a:endParaRPr lang="en-US" dirty="0"/>
           </a:p>
@@ -2291,7 +2316,7 @@
           <a:p>
             <a:fld id="{D4630D1D-EC81-4D12-BBAE-7AD5C46FE905}" type="datetimeFigureOut">
               <a:rPr lang="en-US" dirty="0"/>
-              <a:t>8/7/2026</a:t>
+              <a:t>8/12/2026</a:t>
             </a:fld>
             <a:endParaRPr lang="en-US" dirty="0"/>
           </a:p>
@@ -2553,7 +2578,7 @@
           <a:p>
             <a:fld id="{D4630D1D-EC81-4D12-BBAE-7AD5C46FE905}" type="datetimeFigureOut">
               <a:rPr lang="en-US" dirty="0"/>
-              <a:t>8/7/2026</a:t>
+              <a:t>8/12/2026</a:t>
             </a:fld>
             <a:endParaRPr lang="en-US" dirty="0"/>
           </a:p>
@@ -2803,7 +2828,7 @@
           <a:p>
             <a:fld id="{D4630D1D-EC81-4D12-BBAE-7AD5C46FE905}" type="datetimeFigureOut">
               <a:rPr lang="en-US" dirty="0"/>
-              <a:t>8/7/2026</a:t>
+              <a:t>8/12/2026</a:t>
             </a:fld>
             <a:endParaRPr lang="en-US" dirty="0"/>
           </a:p>
@@ -3193,7 +3218,7 @@
           <a:p>
             <a:fld id="{D4630D1D-EC81-4D12-BBAE-7AD5C46FE905}" type="datetimeFigureOut">
               <a:rPr lang="en-US" dirty="0"/>
-              <a:t>8/7/2026</a:t>
+              <a:t>8/12/2026</a:t>
             </a:fld>
             <a:endParaRPr lang="en-US" dirty="0"/>
           </a:p>
@@ -3325,7 +3350,7 @@
           <a:p>
             <a:fld id="{D4630D1D-EC81-4D12-BBAE-7AD5C46FE905}" type="datetimeFigureOut">
               <a:rPr lang="en-US" dirty="0"/>
-              <a:t>8/7/2026</a:t>
+              <a:t>8/12/2026</a:t>
             </a:fld>
             <a:endParaRPr lang="en-US" dirty="0"/>
           </a:p>
@@ -3430,7 +3455,7 @@
           <a:p>
             <a:fld id="{D4630D1D-EC81-4D12-BBAE-7AD5C46FE905}" type="datetimeFigureOut">
               <a:rPr lang="en-US" dirty="0"/>
-              <a:t>8/7/2026</a:t>
+              <a:t>8/12/2026</a:t>
             </a:fld>
             <a:endParaRPr lang="en-US" dirty="0"/>
           </a:p>
@@ -3725,7 +3750,7 @@
           <a:p>
             <a:fld id="{D4630D1D-EC81-4D12-BBAE-7AD5C46FE905}" type="datetimeFigureOut">
               <a:rPr lang="en-US" dirty="0"/>
-              <a:t>8/7/2026</a:t>
+              <a:t>8/12/2026</a:t>
             </a:fld>
             <a:endParaRPr lang="en-US" dirty="0"/>
           </a:p>
@@ -3998,7 +4023,7 @@
           <a:p>
             <a:fld id="{D4630D1D-EC81-4D12-BBAE-7AD5C46FE905}" type="datetimeFigureOut">
               <a:rPr lang="en-US" dirty="0"/>
-              <a:t>8/7/2026</a:t>
+              <a:t>8/12/2026</a:t>
             </a:fld>
             <a:endParaRPr lang="en-US" dirty="0"/>
           </a:p>
@@ -4228,7 +4253,7 @@
           <a:p>
             <a:fld id="{D4630D1D-EC81-4D12-BBAE-7AD5C46FE905}" type="datetimeFigureOut">
               <a:rPr lang="en-US" dirty="0"/>
-              <a:t>8/7/2026</a:t>
+              <a:t>8/12/2026</a:t>
             </a:fld>
             <a:endParaRPr lang="en-US" dirty="0"/>
           </a:p>

</xml_diff>